<commit_message>
feat: implement ecommerce storefront architecture including error boundaries, product catalog, cart management, and admin configuration tools
</commit_message>
<xml_diff>
--- a/docs/presentacion.pptx
+++ b/docs/presentacion.pptx
@@ -5,7 +5,7 @@
     <p:sldMasterId id="2147483648" r:id="rId1"/>
   </p:sldMasterIdLst>
   <p:notesMasterIdLst>
-    <p:notesMasterId r:id="rId16"/>
+    <p:notesMasterId r:id="rId17"/>
   </p:notesMasterIdLst>
   <p:sldIdLst>
     <p:sldId id="256" r:id="rId2"/>
@@ -16,12 +16,13 @@
     <p:sldId id="261" r:id="rId7"/>
     <p:sldId id="262" r:id="rId8"/>
     <p:sldId id="263" r:id="rId9"/>
-    <p:sldId id="264" r:id="rId10"/>
-    <p:sldId id="265" r:id="rId11"/>
-    <p:sldId id="266" r:id="rId12"/>
-    <p:sldId id="267" r:id="rId13"/>
-    <p:sldId id="268" r:id="rId14"/>
-    <p:sldId id="269" r:id="rId15"/>
+    <p:sldId id="270" r:id="rId10"/>
+    <p:sldId id="264" r:id="rId11"/>
+    <p:sldId id="265" r:id="rId12"/>
+    <p:sldId id="266" r:id="rId13"/>
+    <p:sldId id="267" r:id="rId14"/>
+    <p:sldId id="268" r:id="rId15"/>
+    <p:sldId id="269" r:id="rId16"/>
   </p:sldIdLst>
   <p:sldSz cx="12192000" cy="6858000"/>
   <p:notesSz cx="6858000" cy="12192000"/>
@@ -623,7 +624,7 @@
           <a:p>
             <a:fld id="{F7021451-1387-4CA6-816F-3879F97B5CBC}" type="slidenum">
               <a:rPr lang="en-US"/>
-              <a:t>10</a:t>
+              <a:t>11</a:t>
             </a:fld>
             <a:endParaRPr lang="en-US"/>
           </a:p>
@@ -707,7 +708,7 @@
           <a:p>
             <a:fld id="{F7021451-1387-4CA6-816F-3879F97B5CBC}" type="slidenum">
               <a:rPr lang="en-US"/>
-              <a:t>11</a:t>
+              <a:t>12</a:t>
             </a:fld>
             <a:endParaRPr lang="en-US"/>
           </a:p>
@@ -791,7 +792,7 @@
           <a:p>
             <a:fld id="{F7021451-1387-4CA6-816F-3879F97B5CBC}" type="slidenum">
               <a:rPr lang="en-US"/>
-              <a:t>12</a:t>
+              <a:t>13</a:t>
             </a:fld>
             <a:endParaRPr lang="en-US"/>
           </a:p>
@@ -875,7 +876,7 @@
           <a:p>
             <a:fld id="{F7021451-1387-4CA6-816F-3879F97B5CBC}" type="slidenum">
               <a:rPr lang="en-US"/>
-              <a:t>13</a:t>
+              <a:t>14</a:t>
             </a:fld>
             <a:endParaRPr lang="en-US"/>
           </a:p>
@@ -959,7 +960,7 @@
           <a:p>
             <a:fld id="{F7021451-1387-4CA6-816F-3879F97B5CBC}" type="slidenum">
               <a:rPr lang="en-US"/>
-              <a:t>14</a:t>
+              <a:t>15</a:t>
             </a:fld>
             <a:endParaRPr lang="en-US"/>
           </a:p>
@@ -1631,7 +1632,7 @@
           <a:p>
             <a:fld id="{F7021451-1387-4CA6-816F-3879F97B5CBC}" type="slidenum">
               <a:rPr lang="en-US"/>
-              <a:t>9</a:t>
+              <a:t>10</a:t>
             </a:fld>
             <a:endParaRPr lang="en-US"/>
           </a:p>
@@ -2306,6 +2307,410 @@
 
 <file path=ppt/slides/slide10.xml><?xml version="1.0" encoding="utf-8"?>
 <p:sld xmlns:a="http://schemas.openxmlformats.org/drawingml/2006/main" xmlns:r="http://schemas.openxmlformats.org/officeDocument/2006/relationships" xmlns:p="http://schemas.openxmlformats.org/presentationml/2006/main">
+  <p:cSld name="Slide 9">
+    <p:bg>
+      <p:bgPr>
+        <a:solidFill>
+          <a:srgbClr val="F8FAFC"/>
+        </a:solidFill>
+        <a:effectLst/>
+      </p:bgPr>
+    </p:bg>
+    <p:spTree>
+      <p:nvGrpSpPr>
+        <p:cNvPr id="1" name=""/>
+        <p:cNvGrpSpPr/>
+        <p:nvPr/>
+      </p:nvGrpSpPr>
+      <p:grpSpPr>
+        <a:xfrm>
+          <a:off x="0" y="0"/>
+          <a:ext cx="0" cy="0"/>
+          <a:chOff x="0" y="0"/>
+          <a:chExt cx="0" cy="0"/>
+        </a:xfrm>
+      </p:grpSpPr>
+      <p:sp>
+        <p:nvSpPr>
+          <p:cNvPr id="2" name="Text 0"/>
+          <p:cNvSpPr/>
+          <p:nvPr/>
+        </p:nvSpPr>
+        <p:spPr>
+          <a:xfrm>
+            <a:off x="548640" y="164592"/>
+            <a:ext cx="11064240" cy="274320"/>
+          </a:xfrm>
+          <a:prstGeom prst="rect">
+            <a:avLst/>
+          </a:prstGeom>
+          <a:noFill/>
+          <a:ln/>
+        </p:spPr>
+        <p:txBody>
+          <a:bodyPr wrap="square" rtlCol="0" anchor="ctr"/>
+          <a:lstStyle/>
+          <a:p>
+            <a:pPr marL="0" indent="0" algn="l">
+              <a:buNone/>
+            </a:pPr>
+            <a:r>
+              <a:rPr lang="en-US" sz="1100" dirty="0">
+                <a:solidFill>
+                  <a:srgbClr val="64748B"/>
+                </a:solidFill>
+                <a:latin typeface="Segoe UI" pitchFamily="34" charset="0"/>
+                <a:ea typeface="Segoe UI" pitchFamily="34" charset="-122"/>
+                <a:cs typeface="Segoe UI" pitchFamily="34" charset="-120"/>
+              </a:rPr>
+              <a:t>Sistema ERP inv-tienda  |  Capacitación de Equipo</a:t>
+            </a:r>
+            <a:endParaRPr lang="en-US" sz="1100" dirty="0"/>
+          </a:p>
+        </p:txBody>
+      </p:sp>
+      <p:sp>
+        <p:nvSpPr>
+          <p:cNvPr id="3" name="Text 1"/>
+          <p:cNvSpPr/>
+          <p:nvPr/>
+        </p:nvSpPr>
+        <p:spPr>
+          <a:xfrm>
+            <a:off x="548640" y="6355080"/>
+            <a:ext cx="5486400" cy="274320"/>
+          </a:xfrm>
+          <a:prstGeom prst="rect">
+            <a:avLst/>
+          </a:prstGeom>
+          <a:noFill/>
+          <a:ln/>
+        </p:spPr>
+        <p:txBody>
+          <a:bodyPr wrap="square" rtlCol="0" anchor="ctr"/>
+          <a:lstStyle/>
+          <a:p>
+            <a:pPr marL="0" indent="0">
+              <a:buNone/>
+            </a:pPr>
+            <a:r>
+              <a:rPr lang="en-US" sz="1100" dirty="0">
+                <a:solidFill>
+                  <a:srgbClr val="64748B"/>
+                </a:solidFill>
+                <a:latin typeface="Segoe UI" pitchFamily="34" charset="0"/>
+                <a:ea typeface="Segoe UI" pitchFamily="34" charset="-122"/>
+                <a:cs typeface="Segoe UI" pitchFamily="34" charset="-120"/>
+              </a:rPr>
+              <a:t>Uso Interno Operativo</a:t>
+            </a:r>
+            <a:endParaRPr lang="en-US" sz="1100" dirty="0"/>
+          </a:p>
+        </p:txBody>
+      </p:sp>
+      <p:sp>
+        <p:nvSpPr>
+          <p:cNvPr id="4" name="Text 2"/>
+          <p:cNvSpPr/>
+          <p:nvPr/>
+        </p:nvSpPr>
+        <p:spPr>
+          <a:xfrm>
+            <a:off x="11064240" y="6355080"/>
+            <a:ext cx="548640" cy="274320"/>
+          </a:xfrm>
+          <a:prstGeom prst="rect">
+            <a:avLst/>
+          </a:prstGeom>
+          <a:noFill/>
+          <a:ln/>
+        </p:spPr>
+        <p:txBody>
+          <a:bodyPr wrap="square" rtlCol="0" anchor="ctr"/>
+          <a:lstStyle/>
+          <a:p>
+            <a:pPr marL="0" indent="0" algn="r">
+              <a:buNone/>
+            </a:pPr>
+            <a:r>
+              <a:rPr lang="en-US" sz="1100" dirty="0">
+                <a:solidFill>
+                  <a:srgbClr val="64748B"/>
+                </a:solidFill>
+                <a:latin typeface="Segoe UI" pitchFamily="34" charset="0"/>
+                <a:ea typeface="Segoe UI" pitchFamily="34" charset="-122"/>
+                <a:cs typeface="Segoe UI" pitchFamily="34" charset="-120"/>
+              </a:rPr>
+              <a:t>9</a:t>
+            </a:r>
+            <a:endParaRPr lang="en-US" sz="1100" dirty="0"/>
+          </a:p>
+        </p:txBody>
+      </p:sp>
+      <p:sp>
+        <p:nvSpPr>
+          <p:cNvPr id="5" name="Text 3"/>
+          <p:cNvSpPr/>
+          <p:nvPr/>
+        </p:nvSpPr>
+        <p:spPr>
+          <a:xfrm>
+            <a:off x="548640" y="548640"/>
+            <a:ext cx="11064240" cy="640080"/>
+          </a:xfrm>
+          <a:prstGeom prst="rect">
+            <a:avLst/>
+          </a:prstGeom>
+          <a:noFill/>
+          <a:ln/>
+        </p:spPr>
+        <p:txBody>
+          <a:bodyPr wrap="square" rtlCol="0" anchor="b"/>
+          <a:lstStyle/>
+          <a:p>
+            <a:pPr marL="0" indent="0">
+              <a:buNone/>
+            </a:pPr>
+            <a:r>
+              <a:rPr lang="en-US" sz="3000" b="1" dirty="0">
+                <a:solidFill>
+                  <a:srgbClr val="0F172A"/>
+                </a:solidFill>
+                <a:latin typeface="Segoe UI" pitchFamily="34" charset="0"/>
+                <a:ea typeface="Segoe UI" pitchFamily="34" charset="-122"/>
+                <a:cs typeface="Segoe UI" pitchFamily="34" charset="-120"/>
+              </a:rPr>
+              <a:t>🎨 El Módulo de Catálogo: La Base de Todo</a:t>
+            </a:r>
+            <a:endParaRPr lang="en-US" sz="3000" dirty="0"/>
+          </a:p>
+        </p:txBody>
+      </p:sp>
+      <p:sp>
+        <p:nvSpPr>
+          <p:cNvPr id="6" name="Shape 4"/>
+          <p:cNvSpPr/>
+          <p:nvPr/>
+        </p:nvSpPr>
+        <p:spPr>
+          <a:xfrm>
+            <a:off x="548640" y="1225296"/>
+            <a:ext cx="11064240" cy="36576"/>
+          </a:xfrm>
+          <a:prstGeom prst="rect">
+            <a:avLst/>
+          </a:prstGeom>
+          <a:solidFill>
+            <a:srgbClr val="3B82F6"/>
+          </a:solidFill>
+          <a:ln/>
+        </p:spPr>
+        <p:txBody>
+          <a:bodyPr/>
+          <a:lstStyle/>
+          <a:p>
+            <a:endParaRPr lang="es-MX"/>
+          </a:p>
+        </p:txBody>
+      </p:sp>
+      <p:sp>
+        <p:nvSpPr>
+          <p:cNvPr id="7" name="Text 5"/>
+          <p:cNvSpPr/>
+          <p:nvPr/>
+        </p:nvSpPr>
+        <p:spPr>
+          <a:xfrm>
+            <a:off x="548640" y="1463040"/>
+            <a:ext cx="11064240" cy="320040"/>
+          </a:xfrm>
+          <a:prstGeom prst="rect">
+            <a:avLst/>
+          </a:prstGeom>
+          <a:noFill/>
+          <a:ln/>
+        </p:spPr>
+        <p:txBody>
+          <a:bodyPr wrap="square" rtlCol="0" anchor="ctr"/>
+          <a:lstStyle/>
+          <a:p>
+            <a:pPr marL="0" indent="0">
+              <a:buNone/>
+            </a:pPr>
+            <a:r>
+              <a:rPr lang="en-US" sz="1800" dirty="0">
+                <a:solidFill>
+                  <a:srgbClr val="1E293B"/>
+                </a:solidFill>
+                <a:latin typeface="Segoe UI" pitchFamily="34" charset="0"/>
+                <a:ea typeface="Segoe UI" pitchFamily="34" charset="-122"/>
+                <a:cs typeface="Segoe UI" pitchFamily="34" charset="-120"/>
+              </a:rPr>
+              <a:t>El catálogo es la biblioteca central de productos. El inventario no podría funcionar sin él:</a:t>
+            </a:r>
+            <a:endParaRPr lang="en-US" sz="1800" dirty="0"/>
+          </a:p>
+        </p:txBody>
+      </p:sp>
+      <p:sp>
+        <p:nvSpPr>
+          <p:cNvPr id="8" name="Text 6"/>
+          <p:cNvSpPr/>
+          <p:nvPr/>
+        </p:nvSpPr>
+        <p:spPr>
+          <a:xfrm>
+            <a:off x="548640" y="2011680"/>
+            <a:ext cx="11064240" cy="2377440"/>
+          </a:xfrm>
+          <a:prstGeom prst="rect">
+            <a:avLst/>
+          </a:prstGeom>
+          <a:noFill/>
+          <a:ln/>
+        </p:spPr>
+        <p:txBody>
+          <a:bodyPr wrap="square" rtlCol="0" anchor="ctr"/>
+          <a:lstStyle/>
+          <a:p>
+            <a:pPr marL="254000" indent="-254000">
+              <a:lnSpc>
+                <a:spcPct val="135000"/>
+              </a:lnSpc>
+              <a:spcAft>
+                <a:spcPts val="1000"/>
+              </a:spcAft>
+              <a:buSzPct val="100000"/>
+              <a:buChar char="•"/>
+            </a:pPr>
+            <a:r>
+              <a:rPr lang="en-US" sz="1800" dirty="0">
+                <a:solidFill>
+                  <a:srgbClr val="1E293B"/>
+                </a:solidFill>
+                <a:latin typeface="Segoe UI" pitchFamily="34" charset="0"/>
+                <a:ea typeface="Segoe UI" pitchFamily="34" charset="-122"/>
+                <a:cs typeface="Segoe UI" pitchFamily="34" charset="-120"/>
+              </a:rPr>
+              <a:t>🏷️ Ficha de Identidad: Código único (SKU), Nombre descriptivo, Familia y Marca.
+📐 Variantes y Atributos: Tallas (CH, M, G, XL...), Colores con muestra visual, Tipo de tela y Género.
+📦 Cajas y Empaques: Número de piezas por caja y surtido de tallas / colores.
+🖼️ Fotografías Oficiales: Imágenes en alta calidad del producto real.</a:t>
+            </a:r>
+            <a:endParaRPr lang="en-US" sz="1800" dirty="0"/>
+          </a:p>
+        </p:txBody>
+      </p:sp>
+      <p:sp>
+        <p:nvSpPr>
+          <p:cNvPr id="9" name="Shape 7"/>
+          <p:cNvSpPr/>
+          <p:nvPr/>
+        </p:nvSpPr>
+        <p:spPr>
+          <a:xfrm>
+            <a:off x="548640" y="4754880"/>
+            <a:ext cx="11064240" cy="914400"/>
+          </a:xfrm>
+          <a:prstGeom prst="roundRect">
+            <a:avLst>
+              <a:gd name="adj" fmla="val 8000"/>
+            </a:avLst>
+          </a:prstGeom>
+          <a:solidFill>
+            <a:srgbClr val="DBEAFE"/>
+          </a:solidFill>
+          <a:ln w="12700">
+            <a:solidFill>
+              <a:srgbClr val="DBEAFE"/>
+            </a:solidFill>
+            <a:prstDash val="solid"/>
+          </a:ln>
+        </p:spPr>
+        <p:txBody>
+          <a:bodyPr/>
+          <a:lstStyle/>
+          <a:p>
+            <a:endParaRPr lang="es-MX"/>
+          </a:p>
+        </p:txBody>
+      </p:sp>
+      <p:sp>
+        <p:nvSpPr>
+          <p:cNvPr id="10" name="Shape 8"/>
+          <p:cNvSpPr/>
+          <p:nvPr/>
+        </p:nvSpPr>
+        <p:spPr>
+          <a:xfrm>
+            <a:off x="548640" y="4754880"/>
+            <a:ext cx="73152" cy="914400"/>
+          </a:xfrm>
+          <a:prstGeom prst="rect">
+            <a:avLst/>
+          </a:prstGeom>
+          <a:solidFill>
+            <a:srgbClr val="2563EB"/>
+          </a:solidFill>
+          <a:ln/>
+        </p:spPr>
+        <p:txBody>
+          <a:bodyPr/>
+          <a:lstStyle/>
+          <a:p>
+            <a:endParaRPr lang="es-MX"/>
+          </a:p>
+        </p:txBody>
+      </p:sp>
+      <p:sp>
+        <p:nvSpPr>
+          <p:cNvPr id="11" name="Text 9"/>
+          <p:cNvSpPr/>
+          <p:nvPr/>
+        </p:nvSpPr>
+        <p:spPr>
+          <a:xfrm>
+            <a:off x="822960" y="4754880"/>
+            <a:ext cx="10607040" cy="914400"/>
+          </a:xfrm>
+          <a:prstGeom prst="rect">
+            <a:avLst/>
+          </a:prstGeom>
+          <a:noFill/>
+          <a:ln/>
+        </p:spPr>
+        <p:txBody>
+          <a:bodyPr wrap="square" rtlCol="0" anchor="ctr"/>
+          <a:lstStyle/>
+          <a:p>
+            <a:pPr marL="0" indent="0">
+              <a:buNone/>
+            </a:pPr>
+            <a:r>
+              <a:rPr lang="en-US" sz="1700" dirty="0">
+                <a:solidFill>
+                  <a:srgbClr val="1E40AF"/>
+                </a:solidFill>
+                <a:latin typeface="Segoe UI" pitchFamily="34" charset="0"/>
+                <a:ea typeface="Segoe UI" pitchFamily="34" charset="-122"/>
+                <a:cs typeface="Segoe UI" pitchFamily="34" charset="-120"/>
+              </a:rPr>
+              <a:t>💡 Ventaja: Cuando en bodega capturan una nota, solo buscan el SKU y el sistema autocompleta toda la información sin errores de dedo.</a:t>
+            </a:r>
+            <a:endParaRPr lang="en-US" sz="1700" dirty="0"/>
+          </a:p>
+        </p:txBody>
+      </p:sp>
+    </p:spTree>
+  </p:cSld>
+  <p:clrMapOvr>
+    <a:masterClrMapping/>
+  </p:clrMapOvr>
+</p:sld>
+</file>
+
+<file path=ppt/slides/slide11.xml><?xml version="1.0" encoding="utf-8"?>
+<p:sld xmlns:a="http://schemas.openxmlformats.org/drawingml/2006/main" xmlns:r="http://schemas.openxmlformats.org/officeDocument/2006/relationships" xmlns:p="http://schemas.openxmlformats.org/presentationml/2006/main">
   <p:cSld name="Slide 10">
     <p:bg>
       <p:bgPr>
@@ -2609,7 +3014,7 @@
 </p:sld>
 </file>
 
-<file path=ppt/slides/slide11.xml><?xml version="1.0" encoding="utf-8"?>
+<file path=ppt/slides/slide12.xml><?xml version="1.0" encoding="utf-8"?>
 <p:sld xmlns:a="http://schemas.openxmlformats.org/drawingml/2006/main" xmlns:r="http://schemas.openxmlformats.org/officeDocument/2006/relationships" xmlns:p="http://schemas.openxmlformats.org/presentationml/2006/main">
   <p:cSld name="Slide 11">
     <p:bg>
@@ -2912,7 +3317,7 @@
 </p:sld>
 </file>
 
-<file path=ppt/slides/slide12.xml><?xml version="1.0" encoding="utf-8"?>
+<file path=ppt/slides/slide13.xml><?xml version="1.0" encoding="utf-8"?>
 <p:sld xmlns:a="http://schemas.openxmlformats.org/drawingml/2006/main" xmlns:r="http://schemas.openxmlformats.org/officeDocument/2006/relationships" xmlns:p="http://schemas.openxmlformats.org/presentationml/2006/main">
   <p:cSld name="Slide 12">
     <p:bg>
@@ -3178,7 +3583,7 @@
 </p:sld>
 </file>
 
-<file path=ppt/slides/slide13.xml><?xml version="1.0" encoding="utf-8"?>
+<file path=ppt/slides/slide14.xml><?xml version="1.0" encoding="utf-8"?>
 <p:sld xmlns:a="http://schemas.openxmlformats.org/drawingml/2006/main" xmlns:r="http://schemas.openxmlformats.org/officeDocument/2006/relationships" xmlns:p="http://schemas.openxmlformats.org/presentationml/2006/main">
   <p:cSld name="Slide 13">
     <p:bg>
@@ -3725,7 +4130,7 @@
 </p:sld>
 </file>
 
-<file path=ppt/slides/slide14.xml><?xml version="1.0" encoding="utf-8"?>
+<file path=ppt/slides/slide15.xml><?xml version="1.0" encoding="utf-8"?>
 <p:sld xmlns:a="http://schemas.openxmlformats.org/drawingml/2006/main" xmlns:r="http://schemas.openxmlformats.org/officeDocument/2006/relationships" xmlns:p="http://schemas.openxmlformats.org/presentationml/2006/main">
   <p:cSld name="Slide 14">
     <p:bg>
@@ -5518,14 +5923,14 @@
           <p:nvPr>
             <p:extLst>
               <p:ext uri="{D42A27DB-BD31-4B8C-83A1-F6EECF244321}">
-                <p14:modId xmlns:p14="http://schemas.microsoft.com/office/powerpoint/2010/main" val="1579011935"/>
+                <p14:modId xmlns:p14="http://schemas.microsoft.com/office/powerpoint/2010/main" val="1127187509"/>
               </p:ext>
             </p:extLst>
           </p:nvPr>
         </p:nvGraphicFramePr>
         <p:xfrm>
           <a:off x="548640" y="1965960"/>
-          <a:ext cx="11064240" cy="3571240"/>
+          <a:ext cx="11064240" cy="3332480"/>
         </p:xfrm>
         <a:graphic>
           <a:graphicData uri="http://schemas.openxmlformats.org/drawingml/2006/table">
@@ -5765,7 +6170,7 @@
                   </a:ext>
                 </a:extLst>
               </a:tr>
-              <a:tr h="868680">
+              <a:tr h="471998">
                 <a:tc>
                   <a:txBody>
                     <a:bodyPr/>
@@ -9616,15 +10021,7 @@
 
 <file path=ppt/slides/slide9.xml><?xml version="1.0" encoding="utf-8"?>
 <p:sld xmlns:a="http://schemas.openxmlformats.org/drawingml/2006/main" xmlns:r="http://schemas.openxmlformats.org/officeDocument/2006/relationships" xmlns:p="http://schemas.openxmlformats.org/presentationml/2006/main">
-  <p:cSld name="Slide 9">
-    <p:bg>
-      <p:bgPr>
-        <a:solidFill>
-          <a:srgbClr val="F8FAFC"/>
-        </a:solidFill>
-        <a:effectLst/>
-      </p:bgPr>
-    </p:bg>
+  <p:cSld>
     <p:spTree>
       <p:nvGrpSpPr>
         <p:cNvPr id="1" name=""/>
@@ -9639,378 +10036,12 @@
           <a:chExt cx="0" cy="0"/>
         </a:xfrm>
       </p:grpSpPr>
-      <p:sp>
-        <p:nvSpPr>
-          <p:cNvPr id="2" name="Text 0"/>
-          <p:cNvSpPr/>
-          <p:nvPr/>
-        </p:nvSpPr>
-        <p:spPr>
-          <a:xfrm>
-            <a:off x="548640" y="164592"/>
-            <a:ext cx="11064240" cy="274320"/>
-          </a:xfrm>
-          <a:prstGeom prst="rect">
-            <a:avLst/>
-          </a:prstGeom>
-          <a:noFill/>
-          <a:ln/>
-        </p:spPr>
-        <p:txBody>
-          <a:bodyPr wrap="square" rtlCol="0" anchor="ctr"/>
-          <a:lstStyle/>
-          <a:p>
-            <a:pPr marL="0" indent="0" algn="l">
-              <a:buNone/>
-            </a:pPr>
-            <a:r>
-              <a:rPr lang="en-US" sz="1100" dirty="0">
-                <a:solidFill>
-                  <a:srgbClr val="64748B"/>
-                </a:solidFill>
-                <a:latin typeface="Segoe UI" pitchFamily="34" charset="0"/>
-                <a:ea typeface="Segoe UI" pitchFamily="34" charset="-122"/>
-                <a:cs typeface="Segoe UI" pitchFamily="34" charset="-120"/>
-              </a:rPr>
-              <a:t>Sistema ERP inv-tienda  |  Capacitación de Equipo</a:t>
-            </a:r>
-            <a:endParaRPr lang="en-US" sz="1100" dirty="0"/>
-          </a:p>
-        </p:txBody>
-      </p:sp>
-      <p:sp>
-        <p:nvSpPr>
-          <p:cNvPr id="3" name="Text 1"/>
-          <p:cNvSpPr/>
-          <p:nvPr/>
-        </p:nvSpPr>
-        <p:spPr>
-          <a:xfrm>
-            <a:off x="548640" y="6355080"/>
-            <a:ext cx="5486400" cy="274320"/>
-          </a:xfrm>
-          <a:prstGeom prst="rect">
-            <a:avLst/>
-          </a:prstGeom>
-          <a:noFill/>
-          <a:ln/>
-        </p:spPr>
-        <p:txBody>
-          <a:bodyPr wrap="square" rtlCol="0" anchor="ctr"/>
-          <a:lstStyle/>
-          <a:p>
-            <a:pPr marL="0" indent="0">
-              <a:buNone/>
-            </a:pPr>
-            <a:r>
-              <a:rPr lang="en-US" sz="1100" dirty="0">
-                <a:solidFill>
-                  <a:srgbClr val="64748B"/>
-                </a:solidFill>
-                <a:latin typeface="Segoe UI" pitchFamily="34" charset="0"/>
-                <a:ea typeface="Segoe UI" pitchFamily="34" charset="-122"/>
-                <a:cs typeface="Segoe UI" pitchFamily="34" charset="-120"/>
-              </a:rPr>
-              <a:t>Uso Interno Operativo</a:t>
-            </a:r>
-            <a:endParaRPr lang="en-US" sz="1100" dirty="0"/>
-          </a:p>
-        </p:txBody>
-      </p:sp>
-      <p:sp>
-        <p:nvSpPr>
-          <p:cNvPr id="4" name="Text 2"/>
-          <p:cNvSpPr/>
-          <p:nvPr/>
-        </p:nvSpPr>
-        <p:spPr>
-          <a:xfrm>
-            <a:off x="11064240" y="6355080"/>
-            <a:ext cx="548640" cy="274320"/>
-          </a:xfrm>
-          <a:prstGeom prst="rect">
-            <a:avLst/>
-          </a:prstGeom>
-          <a:noFill/>
-          <a:ln/>
-        </p:spPr>
-        <p:txBody>
-          <a:bodyPr wrap="square" rtlCol="0" anchor="ctr"/>
-          <a:lstStyle/>
-          <a:p>
-            <a:pPr marL="0" indent="0" algn="r">
-              <a:buNone/>
-            </a:pPr>
-            <a:r>
-              <a:rPr lang="en-US" sz="1100" dirty="0">
-                <a:solidFill>
-                  <a:srgbClr val="64748B"/>
-                </a:solidFill>
-                <a:latin typeface="Segoe UI" pitchFamily="34" charset="0"/>
-                <a:ea typeface="Segoe UI" pitchFamily="34" charset="-122"/>
-                <a:cs typeface="Segoe UI" pitchFamily="34" charset="-120"/>
-              </a:rPr>
-              <a:t>9</a:t>
-            </a:r>
-            <a:endParaRPr lang="en-US" sz="1100" dirty="0"/>
-          </a:p>
-        </p:txBody>
-      </p:sp>
-      <p:sp>
-        <p:nvSpPr>
-          <p:cNvPr id="5" name="Text 3"/>
-          <p:cNvSpPr/>
-          <p:nvPr/>
-        </p:nvSpPr>
-        <p:spPr>
-          <a:xfrm>
-            <a:off x="548640" y="548640"/>
-            <a:ext cx="11064240" cy="640080"/>
-          </a:xfrm>
-          <a:prstGeom prst="rect">
-            <a:avLst/>
-          </a:prstGeom>
-          <a:noFill/>
-          <a:ln/>
-        </p:spPr>
-        <p:txBody>
-          <a:bodyPr wrap="square" rtlCol="0" anchor="b"/>
-          <a:lstStyle/>
-          <a:p>
-            <a:pPr marL="0" indent="0">
-              <a:buNone/>
-            </a:pPr>
-            <a:r>
-              <a:rPr lang="en-US" sz="3000" b="1" dirty="0">
-                <a:solidFill>
-                  <a:srgbClr val="0F172A"/>
-                </a:solidFill>
-                <a:latin typeface="Segoe UI" pitchFamily="34" charset="0"/>
-                <a:ea typeface="Segoe UI" pitchFamily="34" charset="-122"/>
-                <a:cs typeface="Segoe UI" pitchFamily="34" charset="-120"/>
-              </a:rPr>
-              <a:t>🎨 El Módulo de Catálogo: La Base de Todo</a:t>
-            </a:r>
-            <a:endParaRPr lang="en-US" sz="3000" dirty="0"/>
-          </a:p>
-        </p:txBody>
-      </p:sp>
-      <p:sp>
-        <p:nvSpPr>
-          <p:cNvPr id="6" name="Shape 4"/>
-          <p:cNvSpPr/>
-          <p:nvPr/>
-        </p:nvSpPr>
-        <p:spPr>
-          <a:xfrm>
-            <a:off x="548640" y="1225296"/>
-            <a:ext cx="11064240" cy="36576"/>
-          </a:xfrm>
-          <a:prstGeom prst="rect">
-            <a:avLst/>
-          </a:prstGeom>
-          <a:solidFill>
-            <a:srgbClr val="3B82F6"/>
-          </a:solidFill>
-          <a:ln/>
-        </p:spPr>
-        <p:txBody>
-          <a:bodyPr/>
-          <a:lstStyle/>
-          <a:p>
-            <a:endParaRPr lang="es-MX"/>
-          </a:p>
-        </p:txBody>
-      </p:sp>
-      <p:sp>
-        <p:nvSpPr>
-          <p:cNvPr id="7" name="Text 5"/>
-          <p:cNvSpPr/>
-          <p:nvPr/>
-        </p:nvSpPr>
-        <p:spPr>
-          <a:xfrm>
-            <a:off x="548640" y="1463040"/>
-            <a:ext cx="11064240" cy="320040"/>
-          </a:xfrm>
-          <a:prstGeom prst="rect">
-            <a:avLst/>
-          </a:prstGeom>
-          <a:noFill/>
-          <a:ln/>
-        </p:spPr>
-        <p:txBody>
-          <a:bodyPr wrap="square" rtlCol="0" anchor="ctr"/>
-          <a:lstStyle/>
-          <a:p>
-            <a:pPr marL="0" indent="0">
-              <a:buNone/>
-            </a:pPr>
-            <a:r>
-              <a:rPr lang="en-US" sz="1800" dirty="0">
-                <a:solidFill>
-                  <a:srgbClr val="1E293B"/>
-                </a:solidFill>
-                <a:latin typeface="Segoe UI" pitchFamily="34" charset="0"/>
-                <a:ea typeface="Segoe UI" pitchFamily="34" charset="-122"/>
-                <a:cs typeface="Segoe UI" pitchFamily="34" charset="-120"/>
-              </a:rPr>
-              <a:t>El catálogo es la biblioteca central de productos. El inventario no podría funcionar sin él:</a:t>
-            </a:r>
-            <a:endParaRPr lang="en-US" sz="1800" dirty="0"/>
-          </a:p>
-        </p:txBody>
-      </p:sp>
-      <p:sp>
-        <p:nvSpPr>
-          <p:cNvPr id="8" name="Text 6"/>
-          <p:cNvSpPr/>
-          <p:nvPr/>
-        </p:nvSpPr>
-        <p:spPr>
-          <a:xfrm>
-            <a:off x="548640" y="2011680"/>
-            <a:ext cx="11064240" cy="2377440"/>
-          </a:xfrm>
-          <a:prstGeom prst="rect">
-            <a:avLst/>
-          </a:prstGeom>
-          <a:noFill/>
-          <a:ln/>
-        </p:spPr>
-        <p:txBody>
-          <a:bodyPr wrap="square" rtlCol="0" anchor="ctr"/>
-          <a:lstStyle/>
-          <a:p>
-            <a:pPr marL="254000" indent="-254000">
-              <a:lnSpc>
-                <a:spcPct val="135000"/>
-              </a:lnSpc>
-              <a:spcAft>
-                <a:spcPts val="1000"/>
-              </a:spcAft>
-              <a:buSzPct val="100000"/>
-              <a:buChar char="•"/>
-            </a:pPr>
-            <a:r>
-              <a:rPr lang="en-US" sz="1800" dirty="0">
-                <a:solidFill>
-                  <a:srgbClr val="1E293B"/>
-                </a:solidFill>
-                <a:latin typeface="Segoe UI" pitchFamily="34" charset="0"/>
-                <a:ea typeface="Segoe UI" pitchFamily="34" charset="-122"/>
-                <a:cs typeface="Segoe UI" pitchFamily="34" charset="-120"/>
-              </a:rPr>
-              <a:t>🏷️ Ficha de Identidad: Código único (SKU), Nombre descriptivo, Familia y Marca.
-📐 Variantes y Atributos: Tallas (CH, M, G, XL...), Colores con muestra visual, Tipo de tela y Género.
-📦 Cajas y Empaques: Número de piezas por caja y surtido de tallas / colores.
-🖼️ Fotografías Oficiales: Imágenes en alta calidad del producto real.</a:t>
-            </a:r>
-            <a:endParaRPr lang="en-US" sz="1800" dirty="0"/>
-          </a:p>
-        </p:txBody>
-      </p:sp>
-      <p:sp>
-        <p:nvSpPr>
-          <p:cNvPr id="9" name="Shape 7"/>
-          <p:cNvSpPr/>
-          <p:nvPr/>
-        </p:nvSpPr>
-        <p:spPr>
-          <a:xfrm>
-            <a:off x="548640" y="4754880"/>
-            <a:ext cx="11064240" cy="914400"/>
-          </a:xfrm>
-          <a:prstGeom prst="roundRect">
-            <a:avLst>
-              <a:gd name="adj" fmla="val 8000"/>
-            </a:avLst>
-          </a:prstGeom>
-          <a:solidFill>
-            <a:srgbClr val="DBEAFE"/>
-          </a:solidFill>
-          <a:ln w="12700">
-            <a:solidFill>
-              <a:srgbClr val="DBEAFE"/>
-            </a:solidFill>
-            <a:prstDash val="solid"/>
-          </a:ln>
-        </p:spPr>
-        <p:txBody>
-          <a:bodyPr/>
-          <a:lstStyle/>
-          <a:p>
-            <a:endParaRPr lang="es-MX"/>
-          </a:p>
-        </p:txBody>
-      </p:sp>
-      <p:sp>
-        <p:nvSpPr>
-          <p:cNvPr id="10" name="Shape 8"/>
-          <p:cNvSpPr/>
-          <p:nvPr/>
-        </p:nvSpPr>
-        <p:spPr>
-          <a:xfrm>
-            <a:off x="548640" y="4754880"/>
-            <a:ext cx="73152" cy="914400"/>
-          </a:xfrm>
-          <a:prstGeom prst="rect">
-            <a:avLst/>
-          </a:prstGeom>
-          <a:solidFill>
-            <a:srgbClr val="2563EB"/>
-          </a:solidFill>
-          <a:ln/>
-        </p:spPr>
-        <p:txBody>
-          <a:bodyPr/>
-          <a:lstStyle/>
-          <a:p>
-            <a:endParaRPr lang="es-MX"/>
-          </a:p>
-        </p:txBody>
-      </p:sp>
-      <p:sp>
-        <p:nvSpPr>
-          <p:cNvPr id="11" name="Text 9"/>
-          <p:cNvSpPr/>
-          <p:nvPr/>
-        </p:nvSpPr>
-        <p:spPr>
-          <a:xfrm>
-            <a:off x="822960" y="4754880"/>
-            <a:ext cx="10607040" cy="914400"/>
-          </a:xfrm>
-          <a:prstGeom prst="rect">
-            <a:avLst/>
-          </a:prstGeom>
-          <a:noFill/>
-          <a:ln/>
-        </p:spPr>
-        <p:txBody>
-          <a:bodyPr wrap="square" rtlCol="0" anchor="ctr"/>
-          <a:lstStyle/>
-          <a:p>
-            <a:pPr marL="0" indent="0">
-              <a:buNone/>
-            </a:pPr>
-            <a:r>
-              <a:rPr lang="en-US" sz="1700" dirty="0">
-                <a:solidFill>
-                  <a:srgbClr val="1E40AF"/>
-                </a:solidFill>
-                <a:latin typeface="Segoe UI" pitchFamily="34" charset="0"/>
-                <a:ea typeface="Segoe UI" pitchFamily="34" charset="-122"/>
-                <a:cs typeface="Segoe UI" pitchFamily="34" charset="-120"/>
-              </a:rPr>
-              <a:t>💡 Ventaja: Cuando en bodega capturan una nota, solo buscan el SKU y el sistema autocompleta toda la información sin errores de dedo.</a:t>
-            </a:r>
-            <a:endParaRPr lang="en-US" sz="1700" dirty="0"/>
-          </a:p>
-        </p:txBody>
-      </p:sp>
     </p:spTree>
+    <p:extLst>
+      <p:ext uri="{BB962C8B-B14F-4D97-AF65-F5344CB8AC3E}">
+        <p14:creationId xmlns:p14="http://schemas.microsoft.com/office/powerpoint/2010/main" val="2399027576"/>
+      </p:ext>
+    </p:extLst>
   </p:cSld>
   <p:clrMapOvr>
     <a:masterClrMapping/>

</xml_diff>